<commit_message>
Rebuild the pitch deck with the before/after slide
Slide 3 is now the two-lane pre-sale before/after that replaced the
too-tight/too-loose slide; the demo beats on slide 6 carry the pre-sale
numbers. The committed file was stale because PowerPoint held it open
when the source was last changed.

Also drops deck/~$KIRIM-pitch.pptx, a PowerPoint lock file that had been
committed by accident, and ignores the pattern.
</commit_message>
<xml_diff>
--- a/deck/KIRIM-pitch.pptx
+++ b/deck/KIRIM-pitch.pptx
@@ -5069,7 +5069,7 @@
                 </a:solidFill>
                 <a:latin typeface="Consolas"/>
               </a:rPr>
-              <a:t>HOW IT WORKS TODAY</a:t>
+              <a:t>BEFORE  /  AFTER</a:t>
             </a:r>
           </a:p>
         </p:txBody>
@@ -5082,8 +5082,8 @@
         </p:nvSpPr>
         <p:spPr>
           <a:xfrm>
-            <a:off x="822960" y="868680"/>
-            <a:ext cx="9601200" cy="914400"/>
+            <a:off x="822960" y="822960"/>
+            <a:ext cx="10058400" cy="822960"/>
           </a:xfrm>
           <a:prstGeom prst="rect">
             <a:avLst/>
@@ -5111,21 +5111,63 @@
                 </a:solidFill>
                 <a:latin typeface="Georgia"/>
               </a:rPr>
-              <a:t>A person decides, city by city. It fails in both directions.</a:t>
-            </a:r>
-          </a:p>
-        </p:txBody>
-      </p:sp>
-      <p:sp>
-        <p:nvSpPr>
-          <p:cNvPr id="5" name="Rectangle 4"/>
+              <a:t>The same sale. One thing changes.</a:t>
+            </a:r>
+          </a:p>
+        </p:txBody>
+      </p:sp>
+      <p:sp>
+        <p:nvSpPr>
+          <p:cNvPr id="5" name="TextBox 4"/>
+          <p:cNvSpPr txBox="1"/>
+          <p:nvPr/>
+        </p:nvSpPr>
+        <p:spPr>
+          <a:xfrm>
+            <a:off x="822960" y="1481328"/>
+            <a:ext cx="9692640" cy="457200"/>
+          </a:xfrm>
+          <a:prstGeom prst="rect">
+            <a:avLst/>
+          </a:prstGeom>
+          <a:noFill/>
+        </p:spPr>
+        <p:txBody>
+          <a:bodyPr wrap="square" lIns="0" rIns="0" tIns="0" bIns="0" anchor="t">
+            <a:spAutoFit/>
+          </a:bodyPr>
+          <a:lstStyle/>
+          <a:p>
+            <a:pPr algn="l">
+              <a:lnSpc>
+                <a:spcPct val="140000"/>
+              </a:lnSpc>
+              <a:spcAft>
+                <a:spcPts val="0"/>
+              </a:spcAft>
+            </a:pPr>
+            <a:r>
+              <a:rPr sz="1300" b="0" i="0">
+                <a:solidFill>
+                  <a:srgbClr val="9B9483"/>
+                </a:solidFill>
+                <a:latin typeface="Segoe UI"/>
+              </a:rPr>
+              <a:t>China pre-sale (期房). Kirim sits between the bank and the developer — it does not stop anyone selling off-plan.</a:t>
+            </a:r>
+          </a:p>
+        </p:txBody>
+      </p:sp>
+      <p:sp>
+        <p:nvSpPr>
+          <p:cNvPr id="6" name="Rectangle 5"/>
           <p:cNvSpPr/>
           <p:nvPr/>
         </p:nvSpPr>
         <p:spPr>
           <a:xfrm>
-            <a:off x="822960" y="2103120"/>
-            <a:ext cx="4998567" cy="1965960"/>
+            <a:off x="822960" y="2148840"/>
+            <a:ext cx="5044287" cy="3401568"/>
           </a:xfrm>
           <a:prstGeom prst="rect">
             <a:avLst/>
@@ -5164,20 +5206,20 @@
       </p:sp>
       <p:sp>
         <p:nvSpPr>
-          <p:cNvPr id="6" name="Rectangle 5"/>
+          <p:cNvPr id="7" name="Rectangle 6"/>
           <p:cNvSpPr/>
           <p:nvPr/>
         </p:nvSpPr>
         <p:spPr>
           <a:xfrm>
-            <a:off x="822960" y="2103120"/>
-            <a:ext cx="45720" cy="1965960"/>
+            <a:off x="822960" y="2148840"/>
+            <a:ext cx="5044287" cy="45720"/>
           </a:xfrm>
           <a:prstGeom prst="rect">
             <a:avLst/>
           </a:prstGeom>
           <a:solidFill>
-            <a:srgbClr val="B07A22"/>
+            <a:srgbClr val="A23B2C"/>
           </a:solidFill>
           <a:ln>
             <a:noFill/>
@@ -5208,14 +5250,14 @@
       </p:sp>
       <p:sp>
         <p:nvSpPr>
-          <p:cNvPr id="7" name="TextBox 6"/>
+          <p:cNvPr id="8" name="TextBox 7"/>
           <p:cNvSpPr txBox="1"/>
           <p:nvPr/>
         </p:nvSpPr>
         <p:spPr>
           <a:xfrm>
-            <a:off x="1097280" y="2340864"/>
-            <a:ext cx="4449927" cy="1554480"/>
+            <a:off x="1078992" y="2368296"/>
+            <a:ext cx="4532223" cy="320040"/>
           </a:xfrm>
           <a:prstGeom prst="rect">
             <a:avLst/>
@@ -5233,50 +5275,787 @@
                 <a:spcPct val="135000"/>
               </a:lnSpc>
               <a:spcAft>
-                <a:spcPts val="1000"/>
-              </a:spcAft>
-            </a:pPr>
-            <a:r>
-              <a:rPr sz="1100" b="1" i="0" spc="14">
-                <a:solidFill>
-                  <a:srgbClr val="B07A22"/>
+                <a:spcPts val="0"/>
+              </a:spcAft>
+            </a:pPr>
+            <a:r>
+              <a:rPr sz="950" b="1" i="0" spc="14">
+                <a:solidFill>
+                  <a:srgbClr val="A23B2C"/>
                 </a:solidFill>
                 <a:latin typeface="Consolas"/>
               </a:rPr>
-              <a:t>TOO TIGHT</a:t>
-            </a:r>
-          </a:p>
-          <a:p>
-            <a:pPr>
-              <a:lnSpc>
-                <a:spcPct val="145000"/>
-              </a:lnSpc>
-              <a:spcAft>
-                <a:spcPts val="0"/>
-              </a:spcAft>
-            </a:pPr>
-            <a:r>
-              <a:rPr sz="1350" b="0" i="0">
+              <a:t>BEFORE  ·  PRE-SALE TODAY</a:t>
+            </a:r>
+          </a:p>
+        </p:txBody>
+      </p:sp>
+      <p:sp>
+        <p:nvSpPr>
+          <p:cNvPr id="9" name="TextBox 8"/>
+          <p:cNvSpPr txBox="1"/>
+          <p:nvPr/>
+        </p:nvSpPr>
+        <p:spPr>
+          <a:xfrm>
+            <a:off x="1078992" y="2788920"/>
+            <a:ext cx="274320" cy="274320"/>
+          </a:xfrm>
+          <a:prstGeom prst="rect">
+            <a:avLst/>
+          </a:prstGeom>
+          <a:noFill/>
+        </p:spPr>
+        <p:txBody>
+          <a:bodyPr wrap="square" lIns="0" rIns="0" tIns="0" bIns="0" anchor="t">
+            <a:spAutoFit/>
+          </a:bodyPr>
+          <a:lstStyle/>
+          <a:p>
+            <a:pPr algn="l">
+              <a:lnSpc>
+                <a:spcPct val="135000"/>
+              </a:lnSpc>
+              <a:spcAft>
+                <a:spcPts val="0"/>
+              </a:spcAft>
+            </a:pPr>
+            <a:r>
+              <a:rPr sz="1100" b="0" i="0">
                 <a:solidFill>
                   <a:srgbClr val="9B9483"/>
                 </a:solidFill>
+                <a:latin typeface="Consolas"/>
+              </a:rPr>
+              <a:t>1</a:t>
+            </a:r>
+          </a:p>
+        </p:txBody>
+      </p:sp>
+      <p:sp>
+        <p:nvSpPr>
+          <p:cNvPr id="10" name="TextBox 9"/>
+          <p:cNvSpPr txBox="1"/>
+          <p:nvPr/>
+        </p:nvSpPr>
+        <p:spPr>
+          <a:xfrm>
+            <a:off x="1389888" y="2779776"/>
+            <a:ext cx="960120" cy="274320"/>
+          </a:xfrm>
+          <a:prstGeom prst="rect">
+            <a:avLst/>
+          </a:prstGeom>
+          <a:noFill/>
+        </p:spPr>
+        <p:txBody>
+          <a:bodyPr wrap="square" lIns="0" rIns="0" tIns="0" bIns="0" anchor="t">
+            <a:spAutoFit/>
+          </a:bodyPr>
+          <a:lstStyle/>
+          <a:p>
+            <a:pPr algn="l">
+              <a:lnSpc>
+                <a:spcPct val="135000"/>
+              </a:lnSpc>
+              <a:spcAft>
+                <a:spcPts val="0"/>
+              </a:spcAft>
+            </a:pPr>
+            <a:r>
+              <a:rPr sz="800" b="0" i="0" spc="12">
+                <a:solidFill>
+                  <a:srgbClr val="7D766A"/>
+                </a:solidFill>
+                <a:latin typeface="Consolas"/>
+              </a:rPr>
+              <a:t>DEVELOPER</a:t>
+            </a:r>
+          </a:p>
+        </p:txBody>
+      </p:sp>
+      <p:sp>
+        <p:nvSpPr>
+          <p:cNvPr id="11" name="TextBox 10"/>
+          <p:cNvSpPr txBox="1"/>
+          <p:nvPr/>
+        </p:nvSpPr>
+        <p:spPr>
+          <a:xfrm>
+            <a:off x="2395728" y="2761488"/>
+            <a:ext cx="3078327" cy="502920"/>
+          </a:xfrm>
+          <a:prstGeom prst="rect">
+            <a:avLst/>
+          </a:prstGeom>
+          <a:noFill/>
+        </p:spPr>
+        <p:txBody>
+          <a:bodyPr wrap="square" lIns="0" rIns="0" tIns="0" bIns="0" anchor="t">
+            <a:spAutoFit/>
+          </a:bodyPr>
+          <a:lstStyle/>
+          <a:p>
+            <a:pPr algn="l">
+              <a:lnSpc>
+                <a:spcPct val="132000"/>
+              </a:lnSpc>
+              <a:spcAft>
+                <a:spcPts val="0"/>
+              </a:spcAft>
+            </a:pPr>
+            <a:r>
+              <a:rPr sz="1200" b="0" i="0">
+                <a:solidFill>
+                  <a:srgbClr val="9B9483"/>
+                </a:solidFill>
                 <a:latin typeface="Segoe UI"/>
               </a:rPr>
-              <a:t>2021 — cities froze withdrawals from escrow. Developers ran out of cash mid-build and construction stopped. A February 2022 framework was issued explicitly to “correct over-tightening”.</a:t>
-            </a:r>
-          </a:p>
-        </p:txBody>
-      </p:sp>
-      <p:sp>
-        <p:nvSpPr>
-          <p:cNvPr id="8" name="Rectangle 7"/>
+              <a:t>Sells the tower off-plan, years before it exists.</a:t>
+            </a:r>
+          </a:p>
+        </p:txBody>
+      </p:sp>
+      <p:sp>
+        <p:nvSpPr>
+          <p:cNvPr id="12" name="TextBox 11"/>
+          <p:cNvSpPr txBox="1"/>
+          <p:nvPr/>
+        </p:nvSpPr>
+        <p:spPr>
+          <a:xfrm>
+            <a:off x="1078992" y="3236976"/>
+            <a:ext cx="274320" cy="274320"/>
+          </a:xfrm>
+          <a:prstGeom prst="rect">
+            <a:avLst/>
+          </a:prstGeom>
+          <a:noFill/>
+        </p:spPr>
+        <p:txBody>
+          <a:bodyPr wrap="square" lIns="0" rIns="0" tIns="0" bIns="0" anchor="t">
+            <a:spAutoFit/>
+          </a:bodyPr>
+          <a:lstStyle/>
+          <a:p>
+            <a:pPr algn="l">
+              <a:lnSpc>
+                <a:spcPct val="135000"/>
+              </a:lnSpc>
+              <a:spcAft>
+                <a:spcPts val="0"/>
+              </a:spcAft>
+            </a:pPr>
+            <a:r>
+              <a:rPr sz="1100" b="0" i="0">
+                <a:solidFill>
+                  <a:srgbClr val="9B9483"/>
+                </a:solidFill>
+                <a:latin typeface="Consolas"/>
+              </a:rPr>
+              <a:t>2</a:t>
+            </a:r>
+          </a:p>
+        </p:txBody>
+      </p:sp>
+      <p:sp>
+        <p:nvSpPr>
+          <p:cNvPr id="13" name="TextBox 12"/>
+          <p:cNvSpPr txBox="1"/>
+          <p:nvPr/>
+        </p:nvSpPr>
+        <p:spPr>
+          <a:xfrm>
+            <a:off x="1389888" y="3227832"/>
+            <a:ext cx="960120" cy="274320"/>
+          </a:xfrm>
+          <a:prstGeom prst="rect">
+            <a:avLst/>
+          </a:prstGeom>
+          <a:noFill/>
+        </p:spPr>
+        <p:txBody>
+          <a:bodyPr wrap="square" lIns="0" rIns="0" tIns="0" bIns="0" anchor="t">
+            <a:spAutoFit/>
+          </a:bodyPr>
+          <a:lstStyle/>
+          <a:p>
+            <a:pPr algn="l">
+              <a:lnSpc>
+                <a:spcPct val="135000"/>
+              </a:lnSpc>
+              <a:spcAft>
+                <a:spcPts val="0"/>
+              </a:spcAft>
+            </a:pPr>
+            <a:r>
+              <a:rPr sz="800" b="0" i="0" spc="12">
+                <a:solidFill>
+                  <a:srgbClr val="7D766A"/>
+                </a:solidFill>
+                <a:latin typeface="Consolas"/>
+              </a:rPr>
+              <a:t>BUYER</a:t>
+            </a:r>
+          </a:p>
+        </p:txBody>
+      </p:sp>
+      <p:sp>
+        <p:nvSpPr>
+          <p:cNvPr id="14" name="TextBox 13"/>
+          <p:cNvSpPr txBox="1"/>
+          <p:nvPr/>
+        </p:nvSpPr>
+        <p:spPr>
+          <a:xfrm>
+            <a:off x="2395728" y="3209544"/>
+            <a:ext cx="3078327" cy="502920"/>
+          </a:xfrm>
+          <a:prstGeom prst="rect">
+            <a:avLst/>
+          </a:prstGeom>
+          <a:noFill/>
+        </p:spPr>
+        <p:txBody>
+          <a:bodyPr wrap="square" lIns="0" rIns="0" tIns="0" bIns="0" anchor="t">
+            <a:spAutoFit/>
+          </a:bodyPr>
+          <a:lstStyle/>
+          <a:p>
+            <a:pPr algn="l">
+              <a:lnSpc>
+                <a:spcPct val="132000"/>
+              </a:lnSpc>
+              <a:spcAft>
+                <a:spcPts val="0"/>
+              </a:spcAft>
+            </a:pPr>
+            <a:r>
+              <a:rPr sz="1200" b="0" i="0">
+                <a:solidFill>
+                  <a:srgbClr val="9B9483"/>
+                </a:solidFill>
+                <a:latin typeface="Segoe UI"/>
+              </a:rPr>
+              <a:t>Pays a 20–30% deposit against a drawing.</a:t>
+            </a:r>
+          </a:p>
+        </p:txBody>
+      </p:sp>
+      <p:sp>
+        <p:nvSpPr>
+          <p:cNvPr id="15" name="TextBox 14"/>
+          <p:cNvSpPr txBox="1"/>
+          <p:nvPr/>
+        </p:nvSpPr>
+        <p:spPr>
+          <a:xfrm>
+            <a:off x="1078992" y="3685032"/>
+            <a:ext cx="274320" cy="274320"/>
+          </a:xfrm>
+          <a:prstGeom prst="rect">
+            <a:avLst/>
+          </a:prstGeom>
+          <a:noFill/>
+        </p:spPr>
+        <p:txBody>
+          <a:bodyPr wrap="square" lIns="0" rIns="0" tIns="0" bIns="0" anchor="t">
+            <a:spAutoFit/>
+          </a:bodyPr>
+          <a:lstStyle/>
+          <a:p>
+            <a:pPr algn="l">
+              <a:lnSpc>
+                <a:spcPct val="135000"/>
+              </a:lnSpc>
+              <a:spcAft>
+                <a:spcPts val="0"/>
+              </a:spcAft>
+            </a:pPr>
+            <a:r>
+              <a:rPr sz="1100" b="0" i="0">
+                <a:solidFill>
+                  <a:srgbClr val="9B9483"/>
+                </a:solidFill>
+                <a:latin typeface="Consolas"/>
+              </a:rPr>
+              <a:t>3</a:t>
+            </a:r>
+          </a:p>
+        </p:txBody>
+      </p:sp>
+      <p:sp>
+        <p:nvSpPr>
+          <p:cNvPr id="16" name="TextBox 15"/>
+          <p:cNvSpPr txBox="1"/>
+          <p:nvPr/>
+        </p:nvSpPr>
+        <p:spPr>
+          <a:xfrm>
+            <a:off x="1389888" y="3675888"/>
+            <a:ext cx="960120" cy="274320"/>
+          </a:xfrm>
+          <a:prstGeom prst="rect">
+            <a:avLst/>
+          </a:prstGeom>
+          <a:noFill/>
+        </p:spPr>
+        <p:txBody>
+          <a:bodyPr wrap="square" lIns="0" rIns="0" tIns="0" bIns="0" anchor="t">
+            <a:spAutoFit/>
+          </a:bodyPr>
+          <a:lstStyle/>
+          <a:p>
+            <a:pPr algn="l">
+              <a:lnSpc>
+                <a:spcPct val="135000"/>
+              </a:lnSpc>
+              <a:spcAft>
+                <a:spcPts val="0"/>
+              </a:spcAft>
+            </a:pPr>
+            <a:r>
+              <a:rPr sz="800" b="0" i="0" spc="12">
+                <a:solidFill>
+                  <a:srgbClr val="7D766A"/>
+                </a:solidFill>
+                <a:latin typeface="Consolas"/>
+              </a:rPr>
+              <a:t>BANK</a:t>
+            </a:r>
+          </a:p>
+        </p:txBody>
+      </p:sp>
+      <p:sp>
+        <p:nvSpPr>
+          <p:cNvPr id="17" name="TextBox 16"/>
+          <p:cNvSpPr txBox="1"/>
+          <p:nvPr/>
+        </p:nvSpPr>
+        <p:spPr>
+          <a:xfrm>
+            <a:off x="2395728" y="3657600"/>
+            <a:ext cx="3078327" cy="502920"/>
+          </a:xfrm>
+          <a:prstGeom prst="rect">
+            <a:avLst/>
+          </a:prstGeom>
+          <a:noFill/>
+        </p:spPr>
+        <p:txBody>
+          <a:bodyPr wrap="square" lIns="0" rIns="0" tIns="0" bIns="0" anchor="t">
+            <a:spAutoFit/>
+          </a:bodyPr>
+          <a:lstStyle/>
+          <a:p>
+            <a:pPr algn="l">
+              <a:lnSpc>
+                <a:spcPct val="132000"/>
+              </a:lnSpc>
+              <a:spcAft>
+                <a:spcPts val="0"/>
+              </a:spcAft>
+            </a:pPr>
+            <a:r>
+              <a:rPr sz="1200" b="0" i="0">
+                <a:solidFill>
+                  <a:srgbClr val="9B9483"/>
+                </a:solidFill>
+                <a:latin typeface="Segoe UI"/>
+              </a:rPr>
+              <a:t>Pays the whole mortgage to the developer, day one.</a:t>
+            </a:r>
+          </a:p>
+        </p:txBody>
+      </p:sp>
+      <p:sp>
+        <p:nvSpPr>
+          <p:cNvPr id="18" name="TextBox 17"/>
+          <p:cNvSpPr txBox="1"/>
+          <p:nvPr/>
+        </p:nvSpPr>
+        <p:spPr>
+          <a:xfrm>
+            <a:off x="1078992" y="4133088"/>
+            <a:ext cx="274320" cy="274320"/>
+          </a:xfrm>
+          <a:prstGeom prst="rect">
+            <a:avLst/>
+          </a:prstGeom>
+          <a:noFill/>
+        </p:spPr>
+        <p:txBody>
+          <a:bodyPr wrap="square" lIns="0" rIns="0" tIns="0" bIns="0" anchor="t">
+            <a:spAutoFit/>
+          </a:bodyPr>
+          <a:lstStyle/>
+          <a:p>
+            <a:pPr algn="l">
+              <a:lnSpc>
+                <a:spcPct val="135000"/>
+              </a:lnSpc>
+              <a:spcAft>
+                <a:spcPts val="0"/>
+              </a:spcAft>
+            </a:pPr>
+            <a:r>
+              <a:rPr sz="1100" b="0" i="0">
+                <a:solidFill>
+                  <a:srgbClr val="9B9483"/>
+                </a:solidFill>
+                <a:latin typeface="Consolas"/>
+              </a:rPr>
+              <a:t>4</a:t>
+            </a:r>
+          </a:p>
+        </p:txBody>
+      </p:sp>
+      <p:sp>
+        <p:nvSpPr>
+          <p:cNvPr id="19" name="TextBox 18"/>
+          <p:cNvSpPr txBox="1"/>
+          <p:nvPr/>
+        </p:nvSpPr>
+        <p:spPr>
+          <a:xfrm>
+            <a:off x="1389888" y="4123944"/>
+            <a:ext cx="960120" cy="274320"/>
+          </a:xfrm>
+          <a:prstGeom prst="rect">
+            <a:avLst/>
+          </a:prstGeom>
+          <a:noFill/>
+        </p:spPr>
+        <p:txBody>
+          <a:bodyPr wrap="square" lIns="0" rIns="0" tIns="0" bIns="0" anchor="t">
+            <a:spAutoFit/>
+          </a:bodyPr>
+          <a:lstStyle/>
+          <a:p>
+            <a:pPr algn="l">
+              <a:lnSpc>
+                <a:spcPct val="135000"/>
+              </a:lnSpc>
+              <a:spcAft>
+                <a:spcPts val="0"/>
+              </a:spcAft>
+            </a:pPr>
+            <a:r>
+              <a:rPr sz="800" b="0" i="0" spc="12">
+                <a:solidFill>
+                  <a:srgbClr val="7D766A"/>
+                </a:solidFill>
+                <a:latin typeface="Consolas"/>
+              </a:rPr>
+              <a:t>BUREAU</a:t>
+            </a:r>
+          </a:p>
+        </p:txBody>
+      </p:sp>
+      <p:sp>
+        <p:nvSpPr>
+          <p:cNvPr id="20" name="TextBox 19"/>
+          <p:cNvSpPr txBox="1"/>
+          <p:nvPr/>
+        </p:nvSpPr>
+        <p:spPr>
+          <a:xfrm>
+            <a:off x="2395728" y="4105656"/>
+            <a:ext cx="3078327" cy="502920"/>
+          </a:xfrm>
+          <a:prstGeom prst="rect">
+            <a:avLst/>
+          </a:prstGeom>
+          <a:noFill/>
+        </p:spPr>
+        <p:txBody>
+          <a:bodyPr wrap="square" lIns="0" rIns="0" tIns="0" bIns="0" anchor="t">
+            <a:spAutoFit/>
+          </a:bodyPr>
+          <a:lstStyle/>
+          <a:p>
+            <a:pPr algn="l">
+              <a:lnSpc>
+                <a:spcPct val="132000"/>
+              </a:lnSpc>
+              <a:spcAft>
+                <a:spcPts val="0"/>
+              </a:spcAft>
+            </a:pPr>
+            <a:r>
+              <a:rPr sz="1200" b="0" i="0">
+                <a:solidFill>
+                  <a:srgbClr val="9B9483"/>
+                </a:solidFill>
+                <a:latin typeface="Segoe UI"/>
+              </a:rPr>
+              <a:t>A local official approves each draw. Rules differ by city.</a:t>
+            </a:r>
+          </a:p>
+        </p:txBody>
+      </p:sp>
+      <p:sp>
+        <p:nvSpPr>
+          <p:cNvPr id="21" name="TextBox 20"/>
+          <p:cNvSpPr txBox="1"/>
+          <p:nvPr/>
+        </p:nvSpPr>
+        <p:spPr>
+          <a:xfrm>
+            <a:off x="1078992" y="4581144"/>
+            <a:ext cx="274320" cy="274320"/>
+          </a:xfrm>
+          <a:prstGeom prst="rect">
+            <a:avLst/>
+          </a:prstGeom>
+          <a:noFill/>
+        </p:spPr>
+        <p:txBody>
+          <a:bodyPr wrap="square" lIns="0" rIns="0" tIns="0" bIns="0" anchor="t">
+            <a:spAutoFit/>
+          </a:bodyPr>
+          <a:lstStyle/>
+          <a:p>
+            <a:pPr algn="l">
+              <a:lnSpc>
+                <a:spcPct val="135000"/>
+              </a:lnSpc>
+              <a:spcAft>
+                <a:spcPts val="0"/>
+              </a:spcAft>
+            </a:pPr>
+            <a:r>
+              <a:rPr sz="1100" b="0" i="0">
+                <a:solidFill>
+                  <a:srgbClr val="A23B2C"/>
+                </a:solidFill>
+                <a:latin typeface="Consolas"/>
+              </a:rPr>
+              <a:t>5</a:t>
+            </a:r>
+          </a:p>
+        </p:txBody>
+      </p:sp>
+      <p:sp>
+        <p:nvSpPr>
+          <p:cNvPr id="22" name="TextBox 21"/>
+          <p:cNvSpPr txBox="1"/>
+          <p:nvPr/>
+        </p:nvSpPr>
+        <p:spPr>
+          <a:xfrm>
+            <a:off x="1389888" y="4572000"/>
+            <a:ext cx="960120" cy="274320"/>
+          </a:xfrm>
+          <a:prstGeom prst="rect">
+            <a:avLst/>
+          </a:prstGeom>
+          <a:noFill/>
+        </p:spPr>
+        <p:txBody>
+          <a:bodyPr wrap="square" lIns="0" rIns="0" tIns="0" bIns="0" anchor="t">
+            <a:spAutoFit/>
+          </a:bodyPr>
+          <a:lstStyle/>
+          <a:p>
+            <a:pPr algn="l">
+              <a:lnSpc>
+                <a:spcPct val="135000"/>
+              </a:lnSpc>
+              <a:spcAft>
+                <a:spcPts val="0"/>
+              </a:spcAft>
+            </a:pPr>
+            <a:r>
+              <a:rPr sz="800" b="0" i="0" spc="12">
+                <a:solidFill>
+                  <a:srgbClr val="7D766A"/>
+                </a:solidFill>
+                <a:latin typeface="Consolas"/>
+              </a:rPr>
+              <a:t>DEVELOPER</a:t>
+            </a:r>
+          </a:p>
+        </p:txBody>
+      </p:sp>
+      <p:sp>
+        <p:nvSpPr>
+          <p:cNvPr id="23" name="TextBox 22"/>
+          <p:cNvSpPr txBox="1"/>
+          <p:nvPr/>
+        </p:nvSpPr>
+        <p:spPr>
+          <a:xfrm>
+            <a:off x="2395728" y="4553712"/>
+            <a:ext cx="3078327" cy="502920"/>
+          </a:xfrm>
+          <a:prstGeom prst="rect">
+            <a:avLst/>
+          </a:prstGeom>
+          <a:noFill/>
+        </p:spPr>
+        <p:txBody>
+          <a:bodyPr wrap="square" lIns="0" rIns="0" tIns="0" bIns="0" anchor="t">
+            <a:spAutoFit/>
+          </a:bodyPr>
+          <a:lstStyle/>
+          <a:p>
+            <a:pPr algn="l">
+              <a:lnSpc>
+                <a:spcPct val="132000"/>
+              </a:lnSpc>
+              <a:spcAft>
+                <a:spcPts val="0"/>
+              </a:spcAft>
+            </a:pPr>
+            <a:r>
+              <a:rPr sz="1200" b="0" i="0">
+                <a:solidFill>
+                  <a:srgbClr val="7A2E2E"/>
+                </a:solidFill>
+                <a:latin typeface="Segoe UI"/>
+              </a:rPr>
+              <a:t>Cash is moved to land, other projects, group debt.</a:t>
+            </a:r>
+          </a:p>
+        </p:txBody>
+      </p:sp>
+      <p:sp>
+        <p:nvSpPr>
+          <p:cNvPr id="24" name="TextBox 23"/>
+          <p:cNvSpPr txBox="1"/>
+          <p:nvPr/>
+        </p:nvSpPr>
+        <p:spPr>
+          <a:xfrm>
+            <a:off x="1078992" y="5029200"/>
+            <a:ext cx="274320" cy="274320"/>
+          </a:xfrm>
+          <a:prstGeom prst="rect">
+            <a:avLst/>
+          </a:prstGeom>
+          <a:noFill/>
+        </p:spPr>
+        <p:txBody>
+          <a:bodyPr wrap="square" lIns="0" rIns="0" tIns="0" bIns="0" anchor="t">
+            <a:spAutoFit/>
+          </a:bodyPr>
+          <a:lstStyle/>
+          <a:p>
+            <a:pPr algn="l">
+              <a:lnSpc>
+                <a:spcPct val="135000"/>
+              </a:lnSpc>
+              <a:spcAft>
+                <a:spcPts val="0"/>
+              </a:spcAft>
+            </a:pPr>
+            <a:r>
+              <a:rPr sz="1100" b="0" i="0">
+                <a:solidFill>
+                  <a:srgbClr val="A23B2C"/>
+                </a:solidFill>
+                <a:latin typeface="Consolas"/>
+              </a:rPr>
+              <a:t>6</a:t>
+            </a:r>
+          </a:p>
+        </p:txBody>
+      </p:sp>
+      <p:sp>
+        <p:nvSpPr>
+          <p:cNvPr id="25" name="TextBox 24"/>
+          <p:cNvSpPr txBox="1"/>
+          <p:nvPr/>
+        </p:nvSpPr>
+        <p:spPr>
+          <a:xfrm>
+            <a:off x="1389888" y="5020056"/>
+            <a:ext cx="960120" cy="274320"/>
+          </a:xfrm>
+          <a:prstGeom prst="rect">
+            <a:avLst/>
+          </a:prstGeom>
+          <a:noFill/>
+        </p:spPr>
+        <p:txBody>
+          <a:bodyPr wrap="square" lIns="0" rIns="0" tIns="0" bIns="0" anchor="t">
+            <a:spAutoFit/>
+          </a:bodyPr>
+          <a:lstStyle/>
+          <a:p>
+            <a:pPr algn="l">
+              <a:lnSpc>
+                <a:spcPct val="135000"/>
+              </a:lnSpc>
+              <a:spcAft>
+                <a:spcPts val="0"/>
+              </a:spcAft>
+            </a:pPr>
+            <a:r>
+              <a:rPr sz="800" b="0" i="0" spc="12">
+                <a:solidFill>
+                  <a:srgbClr val="7D766A"/>
+                </a:solidFill>
+                <a:latin typeface="Consolas"/>
+              </a:rPr>
+              <a:t>BUYER</a:t>
+            </a:r>
+          </a:p>
+        </p:txBody>
+      </p:sp>
+      <p:sp>
+        <p:nvSpPr>
+          <p:cNvPr id="26" name="TextBox 25"/>
+          <p:cNvSpPr txBox="1"/>
+          <p:nvPr/>
+        </p:nvSpPr>
+        <p:spPr>
+          <a:xfrm>
+            <a:off x="2395728" y="5001768"/>
+            <a:ext cx="3078327" cy="502920"/>
+          </a:xfrm>
+          <a:prstGeom prst="rect">
+            <a:avLst/>
+          </a:prstGeom>
+          <a:noFill/>
+        </p:spPr>
+        <p:txBody>
+          <a:bodyPr wrap="square" lIns="0" rIns="0" tIns="0" bIns="0" anchor="t">
+            <a:spAutoFit/>
+          </a:bodyPr>
+          <a:lstStyle/>
+          <a:p>
+            <a:pPr algn="l">
+              <a:lnSpc>
+                <a:spcPct val="132000"/>
+              </a:lnSpc>
+              <a:spcAft>
+                <a:spcPts val="0"/>
+              </a:spcAft>
+            </a:pPr>
+            <a:r>
+              <a:rPr sz="1200" b="0" i="0">
+                <a:solidFill>
+                  <a:srgbClr val="7A2E2E"/>
+                </a:solidFill>
+                <a:latin typeface="Segoe UI"/>
+              </a:rPr>
+              <a:t>Work stops. She keeps paying for a home that does not exist.</a:t>
+            </a:r>
+          </a:p>
+        </p:txBody>
+      </p:sp>
+      <p:sp>
+        <p:nvSpPr>
+          <p:cNvPr id="27" name="Rectangle 26"/>
           <p:cNvSpPr/>
           <p:nvPr/>
         </p:nvSpPr>
         <p:spPr>
           <a:xfrm>
-            <a:off x="6370167" y="2103120"/>
-            <a:ext cx="4998567" cy="1965960"/>
+            <a:off x="6324447" y="2148840"/>
+            <a:ext cx="5044287" cy="3401568"/>
           </a:xfrm>
           <a:prstGeom prst="rect">
             <a:avLst/>
@@ -5315,20 +6094,20 @@
       </p:sp>
       <p:sp>
         <p:nvSpPr>
-          <p:cNvPr id="9" name="Rectangle 8"/>
+          <p:cNvPr id="28" name="Rectangle 27"/>
           <p:cNvSpPr/>
           <p:nvPr/>
         </p:nvSpPr>
         <p:spPr>
           <a:xfrm>
-            <a:off x="6370167" y="2103120"/>
-            <a:ext cx="45720" cy="1965960"/>
+            <a:off x="6324447" y="2148840"/>
+            <a:ext cx="5044287" cy="45720"/>
           </a:xfrm>
           <a:prstGeom prst="rect">
             <a:avLst/>
           </a:prstGeom>
           <a:solidFill>
-            <a:srgbClr val="A23B2C"/>
+            <a:srgbClr val="5E9B79"/>
           </a:solidFill>
           <a:ln>
             <a:noFill/>
@@ -5359,14 +6138,14 @@
       </p:sp>
       <p:sp>
         <p:nvSpPr>
-          <p:cNvPr id="10" name="TextBox 9"/>
+          <p:cNvPr id="29" name="TextBox 28"/>
           <p:cNvSpPr txBox="1"/>
           <p:nvPr/>
         </p:nvSpPr>
         <p:spPr>
           <a:xfrm>
-            <a:off x="6644487" y="2340864"/>
-            <a:ext cx="4449927" cy="1554480"/>
+            <a:off x="6580479" y="2368296"/>
+            <a:ext cx="4532223" cy="320040"/>
           </a:xfrm>
           <a:prstGeom prst="rect">
             <a:avLst/>
@@ -5384,56 +6163,879 @@
                 <a:spcPct val="135000"/>
               </a:lnSpc>
               <a:spcAft>
-                <a:spcPts val="1000"/>
-              </a:spcAft>
-            </a:pPr>
-            <a:r>
-              <a:rPr sz="1100" b="1" i="0" spc="14">
-                <a:solidFill>
-                  <a:srgbClr val="A23B2C"/>
+                <a:spcPts val="0"/>
+              </a:spcAft>
+            </a:pPr>
+            <a:r>
+              <a:rPr sz="950" b="1" i="0" spc="14">
+                <a:solidFill>
+                  <a:srgbClr val="5E9B79"/>
                 </a:solidFill>
                 <a:latin typeface="Consolas"/>
               </a:rPr>
-              <a:t>TOO LOOSE</a:t>
-            </a:r>
-          </a:p>
-          <a:p>
-            <a:pPr>
-              <a:lnSpc>
-                <a:spcPct val="145000"/>
-              </a:lnSpc>
-              <a:spcAft>
-                <a:spcPts val="0"/>
-              </a:spcAft>
-            </a:pPr>
-            <a:r>
-              <a:rPr sz="1350" b="0" i="0">
-                <a:solidFill>
-                  <a:srgbClr val="9B9483"/>
+              <a:t>AFTER  ·  THE SAME SALE, WITH KIRIM</a:t>
+            </a:r>
+          </a:p>
+        </p:txBody>
+      </p:sp>
+      <p:sp>
+        <p:nvSpPr>
+          <p:cNvPr id="30" name="TextBox 29"/>
+          <p:cNvSpPr txBox="1"/>
+          <p:nvPr/>
+        </p:nvSpPr>
+        <p:spPr>
+          <a:xfrm>
+            <a:off x="6580479" y="2788920"/>
+            <a:ext cx="274320" cy="274320"/>
+          </a:xfrm>
+          <a:prstGeom prst="rect">
+            <a:avLst/>
+          </a:prstGeom>
+          <a:noFill/>
+        </p:spPr>
+        <p:txBody>
+          <a:bodyPr wrap="square" lIns="0" rIns="0" tIns="0" bIns="0" anchor="t">
+            <a:spAutoFit/>
+          </a:bodyPr>
+          <a:lstStyle/>
+          <a:p>
+            <a:pPr algn="l">
+              <a:lnSpc>
+                <a:spcPct val="135000"/>
+              </a:lnSpc>
+              <a:spcAft>
+                <a:spcPts val="0"/>
+              </a:spcAft>
+            </a:pPr>
+            <a:r>
+              <a:rPr sz="1100" b="0" i="0">
+                <a:solidFill>
+                  <a:srgbClr val="7D766A"/>
+                </a:solidFill>
+                <a:latin typeface="Consolas"/>
+              </a:rPr>
+              <a:t>1</a:t>
+            </a:r>
+          </a:p>
+        </p:txBody>
+      </p:sp>
+      <p:sp>
+        <p:nvSpPr>
+          <p:cNvPr id="31" name="TextBox 30"/>
+          <p:cNvSpPr txBox="1"/>
+          <p:nvPr/>
+        </p:nvSpPr>
+        <p:spPr>
+          <a:xfrm>
+            <a:off x="6891375" y="2779776"/>
+            <a:ext cx="960120" cy="274320"/>
+          </a:xfrm>
+          <a:prstGeom prst="rect">
+            <a:avLst/>
+          </a:prstGeom>
+          <a:noFill/>
+        </p:spPr>
+        <p:txBody>
+          <a:bodyPr wrap="square" lIns="0" rIns="0" tIns="0" bIns="0" anchor="t">
+            <a:spAutoFit/>
+          </a:bodyPr>
+          <a:lstStyle/>
+          <a:p>
+            <a:pPr algn="l">
+              <a:lnSpc>
+                <a:spcPct val="135000"/>
+              </a:lnSpc>
+              <a:spcAft>
+                <a:spcPts val="0"/>
+              </a:spcAft>
+            </a:pPr>
+            <a:r>
+              <a:rPr sz="800" b="0" i="0" spc="12">
+                <a:solidFill>
+                  <a:srgbClr val="7D766A"/>
+                </a:solidFill>
+                <a:latin typeface="Consolas"/>
+              </a:rPr>
+              <a:t>DEVELOPER</a:t>
+            </a:r>
+          </a:p>
+        </p:txBody>
+      </p:sp>
+      <p:sp>
+        <p:nvSpPr>
+          <p:cNvPr id="32" name="TextBox 31"/>
+          <p:cNvSpPr txBox="1"/>
+          <p:nvPr/>
+        </p:nvSpPr>
+        <p:spPr>
+          <a:xfrm>
+            <a:off x="7897215" y="2761488"/>
+            <a:ext cx="3078327" cy="502920"/>
+          </a:xfrm>
+          <a:prstGeom prst="rect">
+            <a:avLst/>
+          </a:prstGeom>
+          <a:noFill/>
+        </p:spPr>
+        <p:txBody>
+          <a:bodyPr wrap="square" lIns="0" rIns="0" tIns="0" bIns="0" anchor="t">
+            <a:spAutoFit/>
+          </a:bodyPr>
+          <a:lstStyle/>
+          <a:p>
+            <a:pPr algn="l">
+              <a:lnSpc>
+                <a:spcPct val="132000"/>
+              </a:lnSpc>
+              <a:spcAft>
+                <a:spcPts val="0"/>
+              </a:spcAft>
+            </a:pPr>
+            <a:r>
+              <a:rPr sz="1200" b="0" i="0">
+                <a:solidFill>
+                  <a:srgbClr val="7D766A"/>
                 </a:solidFill>
                 <a:latin typeface="Segoe UI"/>
               </a:rPr>
-              <a:t>Evergrande collapsed owing around US$300bn. Buyers who had paid in full were left with unfinished flats, and some stopped paying mortgages on homes that did not exist.</a:t>
-            </a:r>
-          </a:p>
-        </p:txBody>
-      </p:sp>
-      <p:sp>
-        <p:nvSpPr>
-          <p:cNvPr id="11" name="Oval 10"/>
+              <a:t>Sells the tower off-plan, years before it exists.</a:t>
+            </a:r>
+          </a:p>
+        </p:txBody>
+      </p:sp>
+      <p:sp>
+        <p:nvSpPr>
+          <p:cNvPr id="33" name="TextBox 32"/>
+          <p:cNvSpPr txBox="1"/>
+          <p:nvPr/>
+        </p:nvSpPr>
+        <p:spPr>
+          <a:xfrm>
+            <a:off x="10454335" y="2788920"/>
+            <a:ext cx="777240" cy="274320"/>
+          </a:xfrm>
+          <a:prstGeom prst="rect">
+            <a:avLst/>
+          </a:prstGeom>
+          <a:noFill/>
+        </p:spPr>
+        <p:txBody>
+          <a:bodyPr wrap="square" lIns="0" rIns="0" tIns="0" bIns="0" anchor="t">
+            <a:spAutoFit/>
+          </a:bodyPr>
+          <a:lstStyle/>
+          <a:p>
+            <a:pPr algn="r">
+              <a:lnSpc>
+                <a:spcPct val="135000"/>
+              </a:lnSpc>
+              <a:spcAft>
+                <a:spcPts val="0"/>
+              </a:spcAft>
+            </a:pPr>
+            <a:r>
+              <a:rPr sz="750" b="0" i="0">
+                <a:solidFill>
+                  <a:srgbClr val="7D766A"/>
+                </a:solidFill>
+                <a:latin typeface="Consolas"/>
+              </a:rPr>
+              <a:t>unchanged</a:t>
+            </a:r>
+          </a:p>
+        </p:txBody>
+      </p:sp>
+      <p:sp>
+        <p:nvSpPr>
+          <p:cNvPr id="34" name="TextBox 33"/>
+          <p:cNvSpPr txBox="1"/>
+          <p:nvPr/>
+        </p:nvSpPr>
+        <p:spPr>
+          <a:xfrm>
+            <a:off x="6580479" y="3236976"/>
+            <a:ext cx="274320" cy="274320"/>
+          </a:xfrm>
+          <a:prstGeom prst="rect">
+            <a:avLst/>
+          </a:prstGeom>
+          <a:noFill/>
+        </p:spPr>
+        <p:txBody>
+          <a:bodyPr wrap="square" lIns="0" rIns="0" tIns="0" bIns="0" anchor="t">
+            <a:spAutoFit/>
+          </a:bodyPr>
+          <a:lstStyle/>
+          <a:p>
+            <a:pPr algn="l">
+              <a:lnSpc>
+                <a:spcPct val="135000"/>
+              </a:lnSpc>
+              <a:spcAft>
+                <a:spcPts val="0"/>
+              </a:spcAft>
+            </a:pPr>
+            <a:r>
+              <a:rPr sz="1100" b="0" i="0">
+                <a:solidFill>
+                  <a:srgbClr val="7D766A"/>
+                </a:solidFill>
+                <a:latin typeface="Consolas"/>
+              </a:rPr>
+              <a:t>2</a:t>
+            </a:r>
+          </a:p>
+        </p:txBody>
+      </p:sp>
+      <p:sp>
+        <p:nvSpPr>
+          <p:cNvPr id="35" name="TextBox 34"/>
+          <p:cNvSpPr txBox="1"/>
+          <p:nvPr/>
+        </p:nvSpPr>
+        <p:spPr>
+          <a:xfrm>
+            <a:off x="6891375" y="3227832"/>
+            <a:ext cx="960120" cy="274320"/>
+          </a:xfrm>
+          <a:prstGeom prst="rect">
+            <a:avLst/>
+          </a:prstGeom>
+          <a:noFill/>
+        </p:spPr>
+        <p:txBody>
+          <a:bodyPr wrap="square" lIns="0" rIns="0" tIns="0" bIns="0" anchor="t">
+            <a:spAutoFit/>
+          </a:bodyPr>
+          <a:lstStyle/>
+          <a:p>
+            <a:pPr algn="l">
+              <a:lnSpc>
+                <a:spcPct val="135000"/>
+              </a:lnSpc>
+              <a:spcAft>
+                <a:spcPts val="0"/>
+              </a:spcAft>
+            </a:pPr>
+            <a:r>
+              <a:rPr sz="800" b="0" i="0" spc="12">
+                <a:solidFill>
+                  <a:srgbClr val="7D766A"/>
+                </a:solidFill>
+                <a:latin typeface="Consolas"/>
+              </a:rPr>
+              <a:t>BUYER</a:t>
+            </a:r>
+          </a:p>
+        </p:txBody>
+      </p:sp>
+      <p:sp>
+        <p:nvSpPr>
+          <p:cNvPr id="36" name="TextBox 35"/>
+          <p:cNvSpPr txBox="1"/>
+          <p:nvPr/>
+        </p:nvSpPr>
+        <p:spPr>
+          <a:xfrm>
+            <a:off x="7897215" y="3209544"/>
+            <a:ext cx="3078327" cy="502920"/>
+          </a:xfrm>
+          <a:prstGeom prst="rect">
+            <a:avLst/>
+          </a:prstGeom>
+          <a:noFill/>
+        </p:spPr>
+        <p:txBody>
+          <a:bodyPr wrap="square" lIns="0" rIns="0" tIns="0" bIns="0" anchor="t">
+            <a:spAutoFit/>
+          </a:bodyPr>
+          <a:lstStyle/>
+          <a:p>
+            <a:pPr algn="l">
+              <a:lnSpc>
+                <a:spcPct val="132000"/>
+              </a:lnSpc>
+              <a:spcAft>
+                <a:spcPts val="0"/>
+              </a:spcAft>
+            </a:pPr>
+            <a:r>
+              <a:rPr sz="1200" b="0" i="0">
+                <a:solidFill>
+                  <a:srgbClr val="7D766A"/>
+                </a:solidFill>
+                <a:latin typeface="Segoe UI"/>
+              </a:rPr>
+              <a:t>Pays a 20–30% deposit against a drawing.</a:t>
+            </a:r>
+          </a:p>
+        </p:txBody>
+      </p:sp>
+      <p:sp>
+        <p:nvSpPr>
+          <p:cNvPr id="37" name="TextBox 36"/>
+          <p:cNvSpPr txBox="1"/>
+          <p:nvPr/>
+        </p:nvSpPr>
+        <p:spPr>
+          <a:xfrm>
+            <a:off x="10454335" y="3236976"/>
+            <a:ext cx="777240" cy="274320"/>
+          </a:xfrm>
+          <a:prstGeom prst="rect">
+            <a:avLst/>
+          </a:prstGeom>
+          <a:noFill/>
+        </p:spPr>
+        <p:txBody>
+          <a:bodyPr wrap="square" lIns="0" rIns="0" tIns="0" bIns="0" anchor="t">
+            <a:spAutoFit/>
+          </a:bodyPr>
+          <a:lstStyle/>
+          <a:p>
+            <a:pPr algn="r">
+              <a:lnSpc>
+                <a:spcPct val="135000"/>
+              </a:lnSpc>
+              <a:spcAft>
+                <a:spcPts val="0"/>
+              </a:spcAft>
+            </a:pPr>
+            <a:r>
+              <a:rPr sz="750" b="0" i="0">
+                <a:solidFill>
+                  <a:srgbClr val="7D766A"/>
+                </a:solidFill>
+                <a:latin typeface="Consolas"/>
+              </a:rPr>
+              <a:t>unchanged</a:t>
+            </a:r>
+          </a:p>
+        </p:txBody>
+      </p:sp>
+      <p:sp>
+        <p:nvSpPr>
+          <p:cNvPr id="38" name="TextBox 37"/>
+          <p:cNvSpPr txBox="1"/>
+          <p:nvPr/>
+        </p:nvSpPr>
+        <p:spPr>
+          <a:xfrm>
+            <a:off x="6580479" y="3685032"/>
+            <a:ext cx="274320" cy="274320"/>
+          </a:xfrm>
+          <a:prstGeom prst="rect">
+            <a:avLst/>
+          </a:prstGeom>
+          <a:noFill/>
+        </p:spPr>
+        <p:txBody>
+          <a:bodyPr wrap="square" lIns="0" rIns="0" tIns="0" bIns="0" anchor="t">
+            <a:spAutoFit/>
+          </a:bodyPr>
+          <a:lstStyle/>
+          <a:p>
+            <a:pPr algn="l">
+              <a:lnSpc>
+                <a:spcPct val="135000"/>
+              </a:lnSpc>
+              <a:spcAft>
+                <a:spcPts val="0"/>
+              </a:spcAft>
+            </a:pPr>
+            <a:r>
+              <a:rPr sz="1100" b="0" i="0">
+                <a:solidFill>
+                  <a:srgbClr val="5E9B79"/>
+                </a:solidFill>
+                <a:latin typeface="Consolas"/>
+              </a:rPr>
+              <a:t>3</a:t>
+            </a:r>
+          </a:p>
+        </p:txBody>
+      </p:sp>
+      <p:sp>
+        <p:nvSpPr>
+          <p:cNvPr id="39" name="TextBox 38"/>
+          <p:cNvSpPr txBox="1"/>
+          <p:nvPr/>
+        </p:nvSpPr>
+        <p:spPr>
+          <a:xfrm>
+            <a:off x="6891375" y="3675888"/>
+            <a:ext cx="960120" cy="274320"/>
+          </a:xfrm>
+          <a:prstGeom prst="rect">
+            <a:avLst/>
+          </a:prstGeom>
+          <a:noFill/>
+        </p:spPr>
+        <p:txBody>
+          <a:bodyPr wrap="square" lIns="0" rIns="0" tIns="0" bIns="0" anchor="t">
+            <a:spAutoFit/>
+          </a:bodyPr>
+          <a:lstStyle/>
+          <a:p>
+            <a:pPr algn="l">
+              <a:lnSpc>
+                <a:spcPct val="135000"/>
+              </a:lnSpc>
+              <a:spcAft>
+                <a:spcPts val="0"/>
+              </a:spcAft>
+            </a:pPr>
+            <a:r>
+              <a:rPr sz="800" b="0" i="0" spc="12">
+                <a:solidFill>
+                  <a:srgbClr val="7D766A"/>
+                </a:solidFill>
+                <a:latin typeface="Consolas"/>
+              </a:rPr>
+              <a:t>BANK</a:t>
+            </a:r>
+          </a:p>
+        </p:txBody>
+      </p:sp>
+      <p:sp>
+        <p:nvSpPr>
+          <p:cNvPr id="40" name="TextBox 39"/>
+          <p:cNvSpPr txBox="1"/>
+          <p:nvPr/>
+        </p:nvSpPr>
+        <p:spPr>
+          <a:xfrm>
+            <a:off x="7897215" y="3657600"/>
+            <a:ext cx="3078327" cy="502920"/>
+          </a:xfrm>
+          <a:prstGeom prst="rect">
+            <a:avLst/>
+          </a:prstGeom>
+          <a:noFill/>
+        </p:spPr>
+        <p:txBody>
+          <a:bodyPr wrap="square" lIns="0" rIns="0" tIns="0" bIns="0" anchor="t">
+            <a:spAutoFit/>
+          </a:bodyPr>
+          <a:lstStyle/>
+          <a:p>
+            <a:pPr algn="l">
+              <a:lnSpc>
+                <a:spcPct val="132000"/>
+              </a:lnSpc>
+              <a:spcAft>
+                <a:spcPts val="0"/>
+              </a:spcAft>
+            </a:pPr>
+            <a:r>
+              <a:rPr sz="1200" b="0" i="0">
+                <a:solidFill>
+                  <a:srgbClr val="D9D3C5"/>
+                </a:solidFill>
+                <a:latin typeface="Segoe UI"/>
+              </a:rPr>
+              <a:t>Pays the whole mortgage day one — into escrow.</a:t>
+            </a:r>
+          </a:p>
+        </p:txBody>
+      </p:sp>
+      <p:sp>
+        <p:nvSpPr>
+          <p:cNvPr id="41" name="TextBox 40"/>
+          <p:cNvSpPr txBox="1"/>
+          <p:nvPr/>
+        </p:nvSpPr>
+        <p:spPr>
+          <a:xfrm>
+            <a:off x="6580479" y="4133088"/>
+            <a:ext cx="274320" cy="274320"/>
+          </a:xfrm>
+          <a:prstGeom prst="rect">
+            <a:avLst/>
+          </a:prstGeom>
+          <a:noFill/>
+        </p:spPr>
+        <p:txBody>
+          <a:bodyPr wrap="square" lIns="0" rIns="0" tIns="0" bIns="0" anchor="t">
+            <a:spAutoFit/>
+          </a:bodyPr>
+          <a:lstStyle/>
+          <a:p>
+            <a:pPr algn="l">
+              <a:lnSpc>
+                <a:spcPct val="135000"/>
+              </a:lnSpc>
+              <a:spcAft>
+                <a:spcPts val="0"/>
+              </a:spcAft>
+            </a:pPr>
+            <a:r>
+              <a:rPr sz="1100" b="0" i="0">
+                <a:solidFill>
+                  <a:srgbClr val="5E9B79"/>
+                </a:solidFill>
+                <a:latin typeface="Consolas"/>
+              </a:rPr>
+              <a:t>4</a:t>
+            </a:r>
+          </a:p>
+        </p:txBody>
+      </p:sp>
+      <p:sp>
+        <p:nvSpPr>
+          <p:cNvPr id="42" name="TextBox 41"/>
+          <p:cNvSpPr txBox="1"/>
+          <p:nvPr/>
+        </p:nvSpPr>
+        <p:spPr>
+          <a:xfrm>
+            <a:off x="6891375" y="4123944"/>
+            <a:ext cx="960120" cy="274320"/>
+          </a:xfrm>
+          <a:prstGeom prst="rect">
+            <a:avLst/>
+          </a:prstGeom>
+          <a:noFill/>
+        </p:spPr>
+        <p:txBody>
+          <a:bodyPr wrap="square" lIns="0" rIns="0" tIns="0" bIns="0" anchor="t">
+            <a:spAutoFit/>
+          </a:bodyPr>
+          <a:lstStyle/>
+          <a:p>
+            <a:pPr algn="l">
+              <a:lnSpc>
+                <a:spcPct val="135000"/>
+              </a:lnSpc>
+              <a:spcAft>
+                <a:spcPts val="0"/>
+              </a:spcAft>
+            </a:pPr>
+            <a:r>
+              <a:rPr sz="800" b="0" i="0" spc="12">
+                <a:solidFill>
+                  <a:srgbClr val="7D766A"/>
+                </a:solidFill>
+                <a:latin typeface="Consolas"/>
+              </a:rPr>
+              <a:t>XRPL</a:t>
+            </a:r>
+          </a:p>
+        </p:txBody>
+      </p:sp>
+      <p:sp>
+        <p:nvSpPr>
+          <p:cNvPr id="43" name="TextBox 42"/>
+          <p:cNvSpPr txBox="1"/>
+          <p:nvPr/>
+        </p:nvSpPr>
+        <p:spPr>
+          <a:xfrm>
+            <a:off x="7897215" y="4105656"/>
+            <a:ext cx="3078327" cy="502920"/>
+          </a:xfrm>
+          <a:prstGeom prst="rect">
+            <a:avLst/>
+          </a:prstGeom>
+          <a:noFill/>
+        </p:spPr>
+        <p:txBody>
+          <a:bodyPr wrap="square" lIns="0" rIns="0" tIns="0" bIns="0" anchor="t">
+            <a:spAutoFit/>
+          </a:bodyPr>
+          <a:lstStyle/>
+          <a:p>
+            <a:pPr algn="l">
+              <a:lnSpc>
+                <a:spcPct val="132000"/>
+              </a:lnSpc>
+              <a:spcAft>
+                <a:spcPts val="0"/>
+              </a:spcAft>
+            </a:pPr>
+            <a:r>
+              <a:rPr sz="1200" b="0" i="0">
+                <a:solidFill>
+                  <a:srgbClr val="D9D3C5"/>
+                </a:solidFill>
+                <a:latin typeface="Segoe UI"/>
+              </a:rPr>
+              <a:t>A crypto-condition approves each draw. No official to lobby.</a:t>
+            </a:r>
+          </a:p>
+        </p:txBody>
+      </p:sp>
+      <p:sp>
+        <p:nvSpPr>
+          <p:cNvPr id="44" name="TextBox 43"/>
+          <p:cNvSpPr txBox="1"/>
+          <p:nvPr/>
+        </p:nvSpPr>
+        <p:spPr>
+          <a:xfrm>
+            <a:off x="6580479" y="4581144"/>
+            <a:ext cx="274320" cy="274320"/>
+          </a:xfrm>
+          <a:prstGeom prst="rect">
+            <a:avLst/>
+          </a:prstGeom>
+          <a:noFill/>
+        </p:spPr>
+        <p:txBody>
+          <a:bodyPr wrap="square" lIns="0" rIns="0" tIns="0" bIns="0" anchor="t">
+            <a:spAutoFit/>
+          </a:bodyPr>
+          <a:lstStyle/>
+          <a:p>
+            <a:pPr algn="l">
+              <a:lnSpc>
+                <a:spcPct val="135000"/>
+              </a:lnSpc>
+              <a:spcAft>
+                <a:spcPts val="0"/>
+              </a:spcAft>
+            </a:pPr>
+            <a:r>
+              <a:rPr sz="1100" b="0" i="0">
+                <a:solidFill>
+                  <a:srgbClr val="5E9B79"/>
+                </a:solidFill>
+                <a:latin typeface="Consolas"/>
+              </a:rPr>
+              <a:t>5</a:t>
+            </a:r>
+          </a:p>
+        </p:txBody>
+      </p:sp>
+      <p:sp>
+        <p:nvSpPr>
+          <p:cNvPr id="45" name="TextBox 44"/>
+          <p:cNvSpPr txBox="1"/>
+          <p:nvPr/>
+        </p:nvSpPr>
+        <p:spPr>
+          <a:xfrm>
+            <a:off x="6891375" y="4572000"/>
+            <a:ext cx="960120" cy="274320"/>
+          </a:xfrm>
+          <a:prstGeom prst="rect">
+            <a:avLst/>
+          </a:prstGeom>
+          <a:noFill/>
+        </p:spPr>
+        <p:txBody>
+          <a:bodyPr wrap="square" lIns="0" rIns="0" tIns="0" bIns="0" anchor="t">
+            <a:spAutoFit/>
+          </a:bodyPr>
+          <a:lstStyle/>
+          <a:p>
+            <a:pPr algn="l">
+              <a:lnSpc>
+                <a:spcPct val="135000"/>
+              </a:lnSpc>
+              <a:spcAft>
+                <a:spcPts val="0"/>
+              </a:spcAft>
+            </a:pPr>
+            <a:r>
+              <a:rPr sz="800" b="0" i="0" spc="12">
+                <a:solidFill>
+                  <a:srgbClr val="7D766A"/>
+                </a:solidFill>
+                <a:latin typeface="Consolas"/>
+              </a:rPr>
+              <a:t>AGENT</a:t>
+            </a:r>
+          </a:p>
+        </p:txBody>
+      </p:sp>
+      <p:sp>
+        <p:nvSpPr>
+          <p:cNvPr id="46" name="TextBox 45"/>
+          <p:cNvSpPr txBox="1"/>
+          <p:nvPr/>
+        </p:nvSpPr>
+        <p:spPr>
+          <a:xfrm>
+            <a:off x="7897215" y="4553712"/>
+            <a:ext cx="3078327" cy="502920"/>
+          </a:xfrm>
+          <a:prstGeom prst="rect">
+            <a:avLst/>
+          </a:prstGeom>
+          <a:noFill/>
+        </p:spPr>
+        <p:txBody>
+          <a:bodyPr wrap="square" lIns="0" rIns="0" tIns="0" bIns="0" anchor="t">
+            <a:spAutoFit/>
+          </a:bodyPr>
+          <a:lstStyle/>
+          <a:p>
+            <a:pPr algn="l">
+              <a:lnSpc>
+                <a:spcPct val="132000"/>
+              </a:lnSpc>
+              <a:spcAft>
+                <a:spcPts val="0"/>
+              </a:spcAft>
+            </a:pPr>
+            <a:r>
+              <a:rPr sz="1200" b="0" i="0">
+                <a:solidFill>
+                  <a:srgbClr val="D9D3C5"/>
+                </a:solidFill>
+                <a:latin typeface="Segoe UI"/>
+              </a:rPr>
+              <a:t>Examines the evidence. Releases in ~4s, or holds and says why.</a:t>
+            </a:r>
+          </a:p>
+        </p:txBody>
+      </p:sp>
+      <p:sp>
+        <p:nvSpPr>
+          <p:cNvPr id="47" name="TextBox 46"/>
+          <p:cNvSpPr txBox="1"/>
+          <p:nvPr/>
+        </p:nvSpPr>
+        <p:spPr>
+          <a:xfrm>
+            <a:off x="6580479" y="5029200"/>
+            <a:ext cx="274320" cy="274320"/>
+          </a:xfrm>
+          <a:prstGeom prst="rect">
+            <a:avLst/>
+          </a:prstGeom>
+          <a:noFill/>
+        </p:spPr>
+        <p:txBody>
+          <a:bodyPr wrap="square" lIns="0" rIns="0" tIns="0" bIns="0" anchor="t">
+            <a:spAutoFit/>
+          </a:bodyPr>
+          <a:lstStyle/>
+          <a:p>
+            <a:pPr algn="l">
+              <a:lnSpc>
+                <a:spcPct val="135000"/>
+              </a:lnSpc>
+              <a:spcAft>
+                <a:spcPts val="0"/>
+              </a:spcAft>
+            </a:pPr>
+            <a:r>
+              <a:rPr sz="1100" b="0" i="0">
+                <a:solidFill>
+                  <a:srgbClr val="5E9B79"/>
+                </a:solidFill>
+                <a:latin typeface="Consolas"/>
+              </a:rPr>
+              <a:t>6</a:t>
+            </a:r>
+          </a:p>
+        </p:txBody>
+      </p:sp>
+      <p:sp>
+        <p:nvSpPr>
+          <p:cNvPr id="48" name="TextBox 47"/>
+          <p:cNvSpPr txBox="1"/>
+          <p:nvPr/>
+        </p:nvSpPr>
+        <p:spPr>
+          <a:xfrm>
+            <a:off x="6891375" y="5020056"/>
+            <a:ext cx="960120" cy="274320"/>
+          </a:xfrm>
+          <a:prstGeom prst="rect">
+            <a:avLst/>
+          </a:prstGeom>
+          <a:noFill/>
+        </p:spPr>
+        <p:txBody>
+          <a:bodyPr wrap="square" lIns="0" rIns="0" tIns="0" bIns="0" anchor="t">
+            <a:spAutoFit/>
+          </a:bodyPr>
+          <a:lstStyle/>
+          <a:p>
+            <a:pPr algn="l">
+              <a:lnSpc>
+                <a:spcPct val="135000"/>
+              </a:lnSpc>
+              <a:spcAft>
+                <a:spcPts val="0"/>
+              </a:spcAft>
+            </a:pPr>
+            <a:r>
+              <a:rPr sz="800" b="0" i="0" spc="12">
+                <a:solidFill>
+                  <a:srgbClr val="7D766A"/>
+                </a:solidFill>
+                <a:latin typeface="Consolas"/>
+              </a:rPr>
+              <a:t>XRPL</a:t>
+            </a:r>
+          </a:p>
+        </p:txBody>
+      </p:sp>
+      <p:sp>
+        <p:nvSpPr>
+          <p:cNvPr id="49" name="TextBox 48"/>
+          <p:cNvSpPr txBox="1"/>
+          <p:nvPr/>
+        </p:nvSpPr>
+        <p:spPr>
+          <a:xfrm>
+            <a:off x="7897215" y="5001768"/>
+            <a:ext cx="3078327" cy="502920"/>
+          </a:xfrm>
+          <a:prstGeom prst="rect">
+            <a:avLst/>
+          </a:prstGeom>
+          <a:noFill/>
+        </p:spPr>
+        <p:txBody>
+          <a:bodyPr wrap="square" lIns="0" rIns="0" tIns="0" bIns="0" anchor="t">
+            <a:spAutoFit/>
+          </a:bodyPr>
+          <a:lstStyle/>
+          <a:p>
+            <a:pPr algn="l">
+              <a:lnSpc>
+                <a:spcPct val="132000"/>
+              </a:lnSpc>
+              <a:spcAft>
+                <a:spcPts val="0"/>
+              </a:spcAft>
+            </a:pPr>
+            <a:r>
+              <a:rPr sz="1200" b="0" i="0">
+                <a:solidFill>
+                  <a:srgbClr val="D9D3C5"/>
+                </a:solidFill>
+                <a:latin typeface="Segoe UI"/>
+              </a:rPr>
+              <a:t>A stage never built expires back to her. No lawsuit.</a:t>
+            </a:r>
+          </a:p>
+        </p:txBody>
+      </p:sp>
+      <p:sp>
+        <p:nvSpPr>
+          <p:cNvPr id="50" name="Rectangle 49"/>
           <p:cNvSpPr/>
           <p:nvPr/>
         </p:nvSpPr>
         <p:spPr>
           <a:xfrm>
-            <a:off x="943660" y="4555540"/>
-            <a:ext cx="764438" cy="764438"/>
-          </a:xfrm>
-          <a:prstGeom prst="ellipse">
-            <a:avLst/>
-          </a:prstGeom>
-          <a:noFill/>
-          <a:ln w="20320">
+            <a:off x="822960" y="5760720"/>
+            <a:ext cx="10545775" cy="566928"/>
+          </a:xfrm>
+          <a:prstGeom prst="rect">
+            <a:avLst/>
+          </a:prstGeom>
+          <a:solidFill>
+            <a:srgbClr val="1A1712"/>
+          </a:solidFill>
+          <a:ln w="9525">
             <a:solidFill>
               <a:srgbClr val="262119"/>
             </a:solidFill>
@@ -5464,14 +7066,100 @@
       </p:sp>
       <p:sp>
         <p:nvSpPr>
-          <p:cNvPr id="12" name="Rectangle 11"/>
+          <p:cNvPr id="51" name="Rectangle 50"/>
           <p:cNvSpPr/>
           <p:nvPr/>
         </p:nvSpPr>
         <p:spPr>
           <a:xfrm>
-            <a:off x="1315821" y="4696358"/>
-            <a:ext cx="26151" cy="261518"/>
+            <a:off x="822960" y="5760720"/>
+            <a:ext cx="45720" cy="566928"/>
+          </a:xfrm>
+          <a:prstGeom prst="rect">
+            <a:avLst/>
+          </a:prstGeom>
+          <a:solidFill>
+            <a:srgbClr val="5E9B79"/>
+          </a:solidFill>
+          <a:ln>
+            <a:noFill/>
+          </a:ln>
+          <a:effectLst/>
+        </p:spPr>
+        <p:style>
+          <a:lnRef idx="1">
+            <a:schemeClr val="accent1"/>
+          </a:lnRef>
+          <a:fillRef idx="3">
+            <a:schemeClr val="accent1"/>
+          </a:fillRef>
+          <a:effectRef idx="2">
+            <a:schemeClr val="accent1"/>
+          </a:effectRef>
+          <a:fontRef idx="minor">
+            <a:schemeClr val="lt1"/>
+          </a:fontRef>
+        </p:style>
+        <p:txBody>
+          <a:bodyPr rtlCol="0" anchor="ctr"/>
+          <a:lstStyle/>
+          <a:p>
+            <a:pPr algn="ctr"/>
+          </a:p>
+        </p:txBody>
+      </p:sp>
+      <p:sp>
+        <p:nvSpPr>
+          <p:cNvPr id="52" name="TextBox 51"/>
+          <p:cNvSpPr txBox="1"/>
+          <p:nvPr/>
+        </p:nvSpPr>
+        <p:spPr>
+          <a:xfrm>
+            <a:off x="1115568" y="5870448"/>
+            <a:ext cx="9960559" cy="411480"/>
+          </a:xfrm>
+          <a:prstGeom prst="rect">
+            <a:avLst/>
+          </a:prstGeom>
+          <a:noFill/>
+        </p:spPr>
+        <p:txBody>
+          <a:bodyPr wrap="square" lIns="0" rIns="0" tIns="0" bIns="0" anchor="t">
+            <a:spAutoFit/>
+          </a:bodyPr>
+          <a:lstStyle/>
+          <a:p>
+            <a:pPr algn="l">
+              <a:lnSpc>
+                <a:spcPct val="130000"/>
+              </a:lnSpc>
+              <a:spcAft>
+                <a:spcPts val="0"/>
+              </a:spcAft>
+            </a:pPr>
+            <a:r>
+              <a:rPr sz="1550" b="0" i="1">
+                <a:solidFill>
+                  <a:srgbClr val="D9D3C5"/>
+                </a:solidFill>
+                <a:latin typeface="Georgia"/>
+              </a:rPr>
+              <a:t>Two of the six steps are identical. The one that changes is whether the money can leave — and everything else follows from that.</a:t>
+            </a:r>
+          </a:p>
+        </p:txBody>
+      </p:sp>
+      <p:sp>
+        <p:nvSpPr>
+          <p:cNvPr id="53" name="Rectangle 52"/>
+          <p:cNvSpPr/>
+          <p:nvPr/>
+        </p:nvSpPr>
+        <p:spPr>
+          <a:xfrm>
+            <a:off x="822960" y="6217920"/>
+            <a:ext cx="10545775" cy="5715"/>
           </a:xfrm>
           <a:prstGeom prst="rect">
             <a:avLst/>
@@ -5508,58 +7196,14 @@
       </p:sp>
       <p:sp>
         <p:nvSpPr>
-          <p:cNvPr id="13" name="Rectangle 12"/>
-          <p:cNvSpPr/>
-          <p:nvPr/>
-        </p:nvSpPr>
-        <p:spPr>
-          <a:xfrm>
-            <a:off x="1325880" y="4927701"/>
-            <a:ext cx="221284" cy="26151"/>
-          </a:xfrm>
-          <a:prstGeom prst="rect">
-            <a:avLst/>
-          </a:prstGeom>
-          <a:solidFill>
-            <a:srgbClr val="262119"/>
-          </a:solidFill>
-          <a:ln>
-            <a:noFill/>
-          </a:ln>
-          <a:effectLst/>
-        </p:spPr>
-        <p:style>
-          <a:lnRef idx="1">
-            <a:schemeClr val="accent1"/>
-          </a:lnRef>
-          <a:fillRef idx="3">
-            <a:schemeClr val="accent1"/>
-          </a:fillRef>
-          <a:effectRef idx="2">
-            <a:schemeClr val="accent1"/>
-          </a:effectRef>
-          <a:fontRef idx="minor">
-            <a:schemeClr val="lt1"/>
-          </a:fontRef>
-        </p:style>
-        <p:txBody>
-          <a:bodyPr rtlCol="0" anchor="ctr"/>
-          <a:lstStyle/>
-          <a:p>
-            <a:pPr algn="ctr"/>
-          </a:p>
-        </p:txBody>
-      </p:sp>
-      <p:sp>
-        <p:nvSpPr>
-          <p:cNvPr id="14" name="TextBox 13"/>
+          <p:cNvPr id="54" name="TextBox 53"/>
           <p:cNvSpPr txBox="1"/>
           <p:nvPr/>
         </p:nvSpPr>
         <p:spPr>
           <a:xfrm>
-            <a:off x="2103120" y="4526280"/>
-            <a:ext cx="9326880" cy="1280160"/>
+            <a:off x="822960" y="6355080"/>
+            <a:ext cx="5272887" cy="274320"/>
           </a:xfrm>
           <a:prstGeom prst="rect">
             <a:avLst/>
@@ -5574,96 +7218,33 @@
           <a:p>
             <a:pPr algn="l">
               <a:lnSpc>
-                <a:spcPct val="150000"/>
-              </a:lnSpc>
-              <a:spcAft>
-                <a:spcPts val="800"/>
-              </a:spcAft>
-            </a:pPr>
-            <a:r>
-              <a:rPr sz="1550" b="0" i="0">
-                <a:solidFill>
-                  <a:srgbClr val="9B9483"/>
-                </a:solidFill>
-                <a:latin typeface="Segoe UI"/>
-              </a:rPr>
-              <a:t>Release is a manual, discretionary decision, taken by officials who cannot possibly inspect every project, under rules that differ in every city.</a:t>
-            </a:r>
-          </a:p>
-          <a:p>
-            <a:pPr>
-              <a:lnSpc>
-                <a:spcPct val="140000"/>
-              </a:lnSpc>
-              <a:spcAft>
-                <a:spcPts val="0"/>
-              </a:spcAft>
-            </a:pPr>
-            <a:r>
-              <a:rPr sz="1700" b="0" i="1">
-                <a:solidFill>
-                  <a:srgbClr val="B07A22"/>
-                </a:solidFill>
-                <a:latin typeface="Georgia"/>
-              </a:rPr>
-              <a:t>Too slow and honest builders starve. Too loose and buyers lose homes they have already paid for.</a:t>
-            </a:r>
-          </a:p>
-        </p:txBody>
-      </p:sp>
-      <p:sp>
-        <p:nvSpPr>
-          <p:cNvPr id="15" name="Rectangle 14"/>
-          <p:cNvSpPr/>
-          <p:nvPr/>
-        </p:nvSpPr>
-        <p:spPr>
-          <a:xfrm>
-            <a:off x="822960" y="6217920"/>
-            <a:ext cx="10545775" cy="5715"/>
-          </a:xfrm>
-          <a:prstGeom prst="rect">
-            <a:avLst/>
-          </a:prstGeom>
-          <a:solidFill>
-            <a:srgbClr val="262119"/>
-          </a:solidFill>
-          <a:ln>
-            <a:noFill/>
-          </a:ln>
-          <a:effectLst/>
-        </p:spPr>
-        <p:style>
-          <a:lnRef idx="1">
-            <a:schemeClr val="accent1"/>
-          </a:lnRef>
-          <a:fillRef idx="3">
-            <a:schemeClr val="accent1"/>
-          </a:fillRef>
-          <a:effectRef idx="2">
-            <a:schemeClr val="accent1"/>
-          </a:effectRef>
-          <a:fontRef idx="minor">
-            <a:schemeClr val="lt1"/>
-          </a:fontRef>
-        </p:style>
-        <p:txBody>
-          <a:bodyPr rtlCol="0" anchor="ctr"/>
-          <a:lstStyle/>
-          <a:p>
-            <a:pPr algn="ctr"/>
-          </a:p>
-        </p:txBody>
-      </p:sp>
-      <p:sp>
-        <p:nvSpPr>
-          <p:cNvPr id="16" name="TextBox 15"/>
+                <a:spcPct val="135000"/>
+              </a:lnSpc>
+              <a:spcAft>
+                <a:spcPts val="0"/>
+              </a:spcAft>
+            </a:pPr>
+            <a:r>
+              <a:rPr sz="950" b="0" i="0" spc="12">
+                <a:solidFill>
+                  <a:srgbClr val="7D766A"/>
+                </a:solidFill>
+                <a:latin typeface="Consolas"/>
+              </a:rPr>
+              <a:t>KIRIM · BEFORE / AFTER</a:t>
+            </a:r>
+          </a:p>
+        </p:txBody>
+      </p:sp>
+      <p:sp>
+        <p:nvSpPr>
+          <p:cNvPr id="55" name="TextBox 54"/>
           <p:cNvSpPr txBox="1"/>
           <p:nvPr/>
         </p:nvSpPr>
         <p:spPr>
           <a:xfrm>
-            <a:off x="822960" y="6355080"/>
+            <a:off x="6095847" y="6355080"/>
             <a:ext cx="5272887" cy="274320"/>
           </a:xfrm>
           <a:prstGeom prst="rect">
@@ -5677,7 +7258,7 @@
           </a:bodyPr>
           <a:lstStyle/>
           <a:p>
-            <a:pPr algn="l">
+            <a:pPr algn="r">
               <a:lnSpc>
                 <a:spcPct val="135000"/>
               </a:lnSpc>
@@ -5692,49 +7273,7 @@
                 </a:solidFill>
                 <a:latin typeface="Consolas"/>
               </a:rPr>
-              <a:t>KIRIM · CURRENT STATE</a:t>
-            </a:r>
-          </a:p>
-        </p:txBody>
-      </p:sp>
-      <p:sp>
-        <p:nvSpPr>
-          <p:cNvPr id="17" name="TextBox 16"/>
-          <p:cNvSpPr txBox="1"/>
-          <p:nvPr/>
-        </p:nvSpPr>
-        <p:spPr>
-          <a:xfrm>
-            <a:off x="6095847" y="6355080"/>
-            <a:ext cx="5272887" cy="274320"/>
-          </a:xfrm>
-          <a:prstGeom prst="rect">
-            <a:avLst/>
-          </a:prstGeom>
-          <a:noFill/>
-        </p:spPr>
-        <p:txBody>
-          <a:bodyPr wrap="square" lIns="0" rIns="0" tIns="0" bIns="0" anchor="t">
-            <a:spAutoFit/>
-          </a:bodyPr>
-          <a:lstStyle/>
-          <a:p>
-            <a:pPr algn="r">
-              <a:lnSpc>
-                <a:spcPct val="135000"/>
-              </a:lnSpc>
-              <a:spcAft>
-                <a:spcPts val="0"/>
-              </a:spcAft>
-            </a:pPr>
-            <a:r>
-              <a:rPr sz="950" b="0" i="0" spc="12">
-                <a:solidFill>
-                  <a:srgbClr val="7D766A"/>
-                </a:solidFill>
-                <a:latin typeface="Consolas"/>
-              </a:rPr>
-              <a:t>02 / TODAY</a:t>
+              <a:t>02 / THE CHANGE</a:t>
             </a:r>
           </a:p>
         </p:txBody>
@@ -7414,7 +8953,7 @@
                 </a:solidFill>
                 <a:latin typeface="Segoe UI"/>
               </a:rPr>
-              <a:t>Time to release a milestone</a:t>
+              <a:t>Time to release a stage draw</a:t>
             </a:r>
           </a:p>
         </p:txBody>
@@ -8478,7 +10017,7 @@
                 </a:solidFill>
                 <a:latin typeface="Georgia"/>
               </a:rPr>
-              <a:t>Three of six milestones in our demo end with no payment at all — held, flagged, or returned.</a:t>
+              <a:t>Three of six stages in our demo end with no payment at all — held, flagged, or returned.</a:t>
             </a:r>
           </a:p>
           <a:p>
@@ -8771,7 +10310,7 @@
                 </a:solidFill>
                 <a:latin typeface="Georgia"/>
               </a:rPr>
-              <a:t>Watch a milestone pay itself. Then watch one refuse to.</a:t>
+              <a:t>Watch a stage pay itself. Then watch one refuse to.</a:t>
             </a:r>
           </a:p>
         </p:txBody>
@@ -9069,7 +10608,7 @@
                 </a:solidFill>
                 <a:latin typeface="Segoe UI"/>
               </a:rPr>
-              <a:t>A photo taken 2.3km off site</a:t>
+              <a:t>A photo taken 2.4km off site</a:t>
             </a:r>
           </a:p>
         </p:txBody>
@@ -9409,7 +10948,7 @@
                 </a:solidFill>
                 <a:latin typeface="Segoe UI"/>
               </a:rPr>
-              <a:t>Above the client's ceiling</a:t>
+              <a:t>Above the buyer's ceiling</a:t>
             </a:r>
           </a:p>
         </p:txBody>
@@ -9579,7 +11118,7 @@
                 </a:solidFill>
                 <a:latin typeface="Segoe UI"/>
               </a:rPr>
-              <a:t>Nothing ever submitted</a:t>
+              <a:t>Completion never presented</a:t>
             </a:r>
           </a:p>
         </p:txBody>

</xml_diff>